<commit_message>
BMC HSR: revise figure legends, OMML equation, table titles and STROBE headings
Co-Authored-By: Tatsuki Onishi <bougtoir@gmail.com>
</commit_message>
<xml_diff>
--- a/documents/BMC_HSR/regional_anaesthesia_figures_BMC_HSR_EN.pptx
+++ b/documents/BMC_HSR/regional_anaesthesia_figures_BMC_HSR_EN.pptx
@@ -3115,7 +3115,7 @@
               <a:rPr b="1" sz="2200">
                 <a:latin typeface="Arial"/>
               </a:rPr>
-              <a:t>Figure 1. Geographic distribution of anaesthesia standardised claim ratios across 335 secondary medical areas of Japan, fiscal year 2022</a:t>
+              <a:t>Figure 1. Geographic distribution of anaesthesia standardised claim ratios across 335 secondary medical areas</a:t>
             </a:r>
           </a:p>
         </p:txBody>
@@ -3170,7 +3170,7 @@
               <a:rPr sz="1200">
                 <a:latin typeface="Arial"/>
               </a:rPr>
-              <a:t>(A) General anaesthesia (L008). (B) Spinal anaesthesia (L004). (C) Epidural anaesthesia as main anaesthetic (L002). (D) Continuous epidural infusion (L003). Choropleth maps shaded by quintile of the standardised claim ratio (national average = 100). Red circles mark secondary medical areas containing at least one university hospital. Areas masked by the data provider owing to low volume are shown in grey.</a:t>
+              <a:t>(A) General anaesthesia (L008). (B) Spinal anaesthesia (L004). (C) Epidural anaesthesia as main anaesthetic (L002). (D) Continuous epidural infusion (L003). Choropleth maps shaded by quintile of the standardised claim ratio (national average = 100). Red circles mark secondary medical areas containing at least one university hospital. Areas masked by the data provider owing to low volume are shown in grey. Fiscal year 2022.</a:t>
             </a:r>
           </a:p>
         </p:txBody>
@@ -3219,7 +3219,7 @@
               <a:rPr b="1" sz="2200">
                 <a:latin typeface="Arial"/>
               </a:rPr>
-              <a:t>Figure 2. University hospital presence and the combined general-anaesthesia plus continuous-epidural measure.</a:t>
+              <a:t>Figure 2. University hospital presence and the combined general-epidural measure.</a:t>
             </a:r>
           </a:p>
         </p:txBody>

</xml_diff>